<commit_message>
Login con 3 intentos y bloqueo en el servidor, clave monster69; clientes como el GR05 (ec.edu.monster, modelo get/set, controlador delgado) con imagen; docs, diagramas y capturas actualizados
</commit_message>
<xml_diff>
--- a/05. DOCUMENTACIÓN/MANUAL_RESTFUL_DOTNET_GR01.pptx
+++ b/05. DOCUMENTACIÓN/MANUAL_RESTFUL_DOTNET_GR01.pptx
@@ -122,12 +122,12 @@
   <p:extLst>
     <p:ext uri="{521415D9-36F7-43E2-AB2F-B90AF26B5E84}">
       <p14:sectionLst xmlns:p14="http://schemas.microsoft.com/office/powerpoint/2010/main">
-        <p14:section name="Inicio" id="{0dfcded1-cd76-eb23-b732-2735b503362b}">
+        <p14:section name="Inicio" id="{3c8115ff-0d62-f8cd-7708-8123a2662637}">
           <p14:sldIdLst>
             <p14:sldId id="256"/>
           </p14:sldIdLst>
         </p14:section>
-        <p14:section name="Solución" id="{9c1a8b8b-43c9-6b3f-94b8-5ec7b906c7f0}">
+        <p14:section name="Solución" id="{303f0a5a-12e5-f724-aad4-f3e85b771eb1}">
           <p14:sldIdLst>
             <p14:sldId id="257"/>
             <p14:sldId id="258"/>
@@ -138,7 +138,7 @@
             <p14:sldId id="263"/>
           </p14:sldIdLst>
         </p14:section>
-        <p14:section name="Clientes" id="{a80db5f0-a006-3dfc-288f-607e84f5c7c3}">
+        <p14:section name="Clientes" id="{3084792d-ad61-7788-da0e-c55f0e4f44ec}">
           <p14:sldIdLst>
             <p14:sldId id="264"/>
             <p14:sldId id="265"/>
@@ -147,13 +147,13 @@
             <p14:sldId id="268"/>
           </p14:sldIdLst>
         </p14:section>
-        <p14:section name="Calidad" id="{5157e6b3-3579-6216-dd19-9b3630801b2c}">
+        <p14:section name="Calidad" id="{79f11576-3723-fc27-b1d4-e3714a2eae40}">
           <p14:sldIdLst>
             <p14:sldId id="269"/>
             <p14:sldId id="270"/>
           </p14:sldIdLst>
         </p14:section>
-        <p14:section name="Cierre" id="{cce459e0-aa95-5d96-6fc3-ff5aa88bf4a1}">
+        <p14:section name="Cierre" id="{3831264a-8f55-b490-703d-23f97a415ecb}">
           <p14:sldIdLst>
             <p14:sldId id="271"/>
           </p14:sldIdLst>
@@ -3197,8 +3197,8 @@
         </p:nvSpPr>
         <p:spPr>
           <a:xfrm>
-            <a:off x="4352544" y="2103983"/>
-            <a:ext cx="7342632" cy="3655874"/>
+            <a:off x="4352544" y="1894600"/>
+            <a:ext cx="7342632" cy="4074641"/>
           </a:xfrm>
           <a:prstGeom prst="rect">
             <a:avLst/>
@@ -3237,8 +3237,8 @@
         </p:blipFill>
         <p:spPr>
           <a:xfrm>
-            <a:off x="4389120" y="2140559"/>
-            <a:ext cx="7269480" cy="3582722"/>
+            <a:off x="4389120" y="1931176"/>
+            <a:ext cx="7269480" cy="4001489"/>
           </a:xfrm>
           <a:prstGeom prst="rect">
             <a:avLst/>
@@ -5734,7 +5734,7 @@
                             <a:srgbClr val="212529"/>
                           </a:solidFill>
                         </a:rPr>
-                        <a:t>monster / clave</a:t>
+                        <a:t>monster / monster69</a:t>
                       </a:r>
                       <a:endParaRPr lang="en-US" sz="1300" dirty="0"/>
                     </a:p>
@@ -5795,7 +5795,7 @@
                             <a:srgbClr val="212529"/>
                           </a:solidFill>
                         </a:rPr>
-                        <a:t>200 · 401 «Usuario o clave incorrectos»</a:t>
+                        <a:t>200 · 401 «Intentos restantes: 2»</a:t>
                       </a:r>
                       <a:endParaRPr lang="en-US" sz="1300" dirty="0"/>
                     </a:p>
@@ -10601,7 +10601,7 @@
                 <a:ea typeface="Consolas" pitchFamily="34" charset="-122"/>
                 <a:cs typeface="Consolas" pitchFamily="34" charset="-120"/>
               </a:rPr>
-              <a:t>  "clave": "monster" }</a:t>
+              <a:t>  "clave": "monster69" }</a:t>
             </a:r>
             <a:endParaRPr lang="en-US" sz="1400" dirty="0"/>
           </a:p>
@@ -14189,7 +14189,7 @@
                 <a:ea typeface="Calibri" pitchFamily="34" charset="-122"/>
                 <a:cs typeface="Calibri" pitchFamily="34" charset="-120"/>
               </a:rPr>
-              <a:t>Login con clave oculta y 3 intentos</a:t>
+              <a:t>Login con clave oculta (los 3 intentos los cuenta el servidor)</a:t>
             </a:r>
             <a:endParaRPr lang="en-US" sz="1500" dirty="0"/>
           </a:p>
@@ -14210,7 +14210,7 @@
                 <a:ea typeface="Calibri" pitchFamily="34" charset="-122"/>
                 <a:cs typeface="Calibri" pitchFamily="34" charset="-120"/>
               </a:rPr>
-              <a:t>401 → «Usuario o clave incorrectos»</a:t>
+              <a:t>401 → «Intentos restantes: N»</a:t>
             </a:r>
             <a:endParaRPr lang="en-US" sz="1500" dirty="0"/>
           </a:p>

</xml_diff>

<commit_message>
Capturas nuevas de consola y escritorio (mensaje de intentos del servidor, imagen); manual y presentacion regenerados
</commit_message>
<xml_diff>
--- a/05. DOCUMENTACIÓN/MANUAL_RESTFUL_DOTNET_GR01.pptx
+++ b/05. DOCUMENTACIÓN/MANUAL_RESTFUL_DOTNET_GR01.pptx
@@ -122,12 +122,12 @@
   <p:extLst>
     <p:ext uri="{521415D9-36F7-43E2-AB2F-B90AF26B5E84}">
       <p14:sectionLst xmlns:p14="http://schemas.microsoft.com/office/powerpoint/2010/main">
-        <p14:section name="Inicio" id="{3c8115ff-0d62-f8cd-7708-8123a2662637}">
+        <p14:section name="Inicio" id="{895ba0f6-f3ba-93a7-861b-0bcf2006143e}">
           <p14:sldIdLst>
             <p14:sldId id="256"/>
           </p14:sldIdLst>
         </p14:section>
-        <p14:section name="Solución" id="{303f0a5a-12e5-f724-aad4-f3e85b771eb1}">
+        <p14:section name="Solución" id="{e04264cc-d5a0-76d4-4c97-d4c4bde505c2}">
           <p14:sldIdLst>
             <p14:sldId id="257"/>
             <p14:sldId id="258"/>
@@ -138,7 +138,7 @@
             <p14:sldId id="263"/>
           </p14:sldIdLst>
         </p14:section>
-        <p14:section name="Clientes" id="{3084792d-ad61-7788-da0e-c55f0e4f44ec}">
+        <p14:section name="Clientes" id="{17259e61-0d6e-fc21-1af4-a85acc1b6d41}">
           <p14:sldIdLst>
             <p14:sldId id="264"/>
             <p14:sldId id="265"/>
@@ -147,13 +147,13 @@
             <p14:sldId id="268"/>
           </p14:sldIdLst>
         </p14:section>
-        <p14:section name="Calidad" id="{79f11576-3723-fc27-b1d4-e3714a2eae40}">
+        <p14:section name="Calidad" id="{c707d7fa-f4f3-80ba-b7ef-c2b750bff02e}">
           <p14:sldIdLst>
             <p14:sldId id="269"/>
             <p14:sldId id="270"/>
           </p14:sldIdLst>
         </p14:section>
-        <p14:section name="Cierre" id="{3831264a-8f55-b490-703d-23f97a415ecb}">
+        <p14:section name="Cierre" id="{cb941811-6ba8-e8f7-277e-49062810928c}">
           <p14:sldIdLst>
             <p14:sldId id="271"/>
           </p14:sldIdLst>
@@ -14287,8 +14287,8 @@
         </p:nvSpPr>
         <p:spPr>
           <a:xfrm>
-            <a:off x="5684955" y="1609344"/>
-            <a:ext cx="4677809" cy="2221992"/>
+            <a:off x="5702803" y="1609344"/>
+            <a:ext cx="4642114" cy="2221992"/>
           </a:xfrm>
           <a:prstGeom prst="rect">
             <a:avLst/>
@@ -14327,8 +14327,8 @@
         </p:blipFill>
         <p:spPr>
           <a:xfrm>
-            <a:off x="5721531" y="1645920"/>
-            <a:ext cx="4604657" cy="2148840"/>
+            <a:off x="5739379" y="1645920"/>
+            <a:ext cx="4568962" cy="2148840"/>
           </a:xfrm>
           <a:prstGeom prst="rect">
             <a:avLst/>
@@ -14343,8 +14343,8 @@
         </p:nvSpPr>
         <p:spPr>
           <a:xfrm>
-            <a:off x="5586984" y="3941064"/>
-            <a:ext cx="4873752" cy="2313432"/>
+            <a:off x="5261468" y="3941064"/>
+            <a:ext cx="5524784" cy="2313432"/>
           </a:xfrm>
           <a:prstGeom prst="rect">
             <a:avLst/>
@@ -14383,8 +14383,8 @@
         </p:blipFill>
         <p:spPr>
           <a:xfrm>
-            <a:off x="5623560" y="3977640"/>
-            <a:ext cx="4800600" cy="2240280"/>
+            <a:off x="5298044" y="3977640"/>
+            <a:ext cx="5451632" cy="2240280"/>
           </a:xfrm>
           <a:prstGeom prst="rect">
             <a:avLst/>

</xml_diff>

<commit_message>
Interfaces Bento y consola MONSTER; diagramas en PowerDesigner; ERS, ECUD, manual y PPT con el formato del grupo
Mismas pantallas que el TI.1.2 (escritorio, web y movil Bento; consola MONSTER)
con los textos de REST. Diagramas UML y de arquitectura en SAP PowerDesigner
(casos de uso, actividad, secuencia, clases y EAM) para el API REST.
ERS y ECUD con indices y tablas por caso de uso; manual y presentacion con el
servidor publicado en IIS y capturas nuevas de los cuatro clientes y Swagger.
</commit_message>
<xml_diff>
--- a/05. DOCUMENTACIÓN/MANUAL_RESTFUL_DOTNET_GR01.pptx
+++ b/05. DOCUMENTACIÓN/MANUAL_RESTFUL_DOTNET_GR01.pptx
@@ -122,12 +122,12 @@
   <p:extLst>
     <p:ext uri="{521415D9-36F7-43E2-AB2F-B90AF26B5E84}">
       <p14:sectionLst xmlns:p14="http://schemas.microsoft.com/office/powerpoint/2010/main">
-        <p14:section name="Inicio" id="{895ba0f6-f3ba-93a7-861b-0bcf2006143e}">
+        <p14:section name="Inicio" id="{5f3666ec-4205-65e3-d172-9fff26b8f660}">
           <p14:sldIdLst>
             <p14:sldId id="256"/>
           </p14:sldIdLst>
         </p14:section>
-        <p14:section name="Solución" id="{e04264cc-d5a0-76d4-4c97-d4c4bde505c2}">
+        <p14:section name="Solución" id="{aecb981a-7f6c-b5ad-e8e3-791074d682c9}">
           <p14:sldIdLst>
             <p14:sldId id="257"/>
             <p14:sldId id="258"/>
@@ -138,7 +138,7 @@
             <p14:sldId id="263"/>
           </p14:sldIdLst>
         </p14:section>
-        <p14:section name="Clientes" id="{17259e61-0d6e-fc21-1af4-a85acc1b6d41}">
+        <p14:section name="Clientes" id="{4457c14c-b705-8d3f-827e-5f6b584f8916}">
           <p14:sldIdLst>
             <p14:sldId id="264"/>
             <p14:sldId id="265"/>
@@ -147,13 +147,13 @@
             <p14:sldId id="268"/>
           </p14:sldIdLst>
         </p14:section>
-        <p14:section name="Calidad" id="{c707d7fa-f4f3-80ba-b7ef-c2b750bff02e}">
+        <p14:section name="Calidad" id="{03b1fdee-d85d-50f3-ee66-3a6eed56babb}">
           <p14:sldIdLst>
             <p14:sldId id="269"/>
             <p14:sldId id="270"/>
           </p14:sldIdLst>
         </p14:section>
-        <p14:section name="Cierre" id="{cb941811-6ba8-e8f7-277e-49062810928c}">
+        <p14:section name="Cierre" id="{558e24d5-7b89-b21b-b355-20392df99be3}">
           <p14:sldIdLst>
             <p14:sldId id="271"/>
           </p14:sldIdLst>
@@ -1354,7 +1354,7 @@
           <a:p>
             <a:r>
               <a:rPr lang="en-US" dirty="0"/>
-              <a:t>Los cuatro clientes hablan HTTP con el API en Kestrel :8086. El servidor se organiza en Controllers, Modelo y Lógica; las credenciales están en appsettings.json.</a:t>
+              <a:t>Los cuatro clientes hablan HTTP con el API publicado en IIS :8086. El servidor se organiza en Controllers, Modelo y Lógica; las credenciales están en appsettings.json.</a:t>
             </a:r>
             <a:endParaRPr lang="en-US" dirty="0"/>
           </a:p>
@@ -3099,7 +3099,7 @@
                 <a:ea typeface="Calibri" pitchFamily="34" charset="-122"/>
                 <a:cs typeface="Calibri" pitchFamily="34" charset="-120"/>
               </a:rPr>
-              <a:t>Menú lateral con color por categoría</a:t>
+              <a:t>Cuadrícula Bento con color por categoría</a:t>
             </a:r>
             <a:endParaRPr lang="en-US" sz="1500" dirty="0"/>
           </a:p>
@@ -3197,8 +3197,8 @@
         </p:nvSpPr>
         <p:spPr>
           <a:xfrm>
-            <a:off x="4352544" y="1894600"/>
-            <a:ext cx="7342632" cy="4074641"/>
+            <a:off x="4352544" y="1700966"/>
+            <a:ext cx="7342632" cy="4461907"/>
           </a:xfrm>
           <a:prstGeom prst="rect">
             <a:avLst/>
@@ -3237,8 +3237,8 @@
         </p:blipFill>
         <p:spPr>
           <a:xfrm>
-            <a:off x="4389120" y="1931176"/>
-            <a:ext cx="7269480" cy="4001489"/>
+            <a:off x="4389120" y="1737542"/>
+            <a:ext cx="7269480" cy="4388755"/>
           </a:xfrm>
           <a:prstGeom prst="rect">
             <a:avLst/>
@@ -3586,8 +3586,8 @@
         </p:nvSpPr>
         <p:spPr>
           <a:xfrm>
-            <a:off x="10103989" y="1655064"/>
-            <a:ext cx="1463302" cy="4553712"/>
+            <a:off x="10118605" y="1655064"/>
+            <a:ext cx="1434070" cy="4553712"/>
           </a:xfrm>
           <a:prstGeom prst="rect">
             <a:avLst/>
@@ -3626,8 +3626,8 @@
         </p:blipFill>
         <p:spPr>
           <a:xfrm>
-            <a:off x="10140565" y="1691640"/>
-            <a:ext cx="1390150" cy="4480560"/>
+            <a:off x="10155181" y="1691640"/>
+            <a:ext cx="1360918" cy="4480560"/>
           </a:xfrm>
           <a:prstGeom prst="rect">
             <a:avLst/>
@@ -3913,13 +3913,69 @@
       </p:sp>
       <p:sp>
         <p:nvSpPr>
-          <p:cNvPr id="6" name="Caja código móvil"/>
+          <p:cNvPr id="6" name="Marco Móvil en la tablet"/>
           <p:cNvSpPr/>
           <p:nvPr/>
         </p:nvSpPr>
         <p:spPr>
           <a:xfrm>
-            <a:off x="4389120" y="1691640"/>
+            <a:off x="5853684" y="1563624"/>
+            <a:ext cx="4340352" cy="2633472"/>
+          </a:xfrm>
+          <a:prstGeom prst="rect">
+            <a:avLst/>
+          </a:prstGeom>
+          <a:solidFill>
+            <a:srgbClr val="FFFFFF"/>
+          </a:solidFill>
+          <a:ln w="12700">
+            <a:solidFill>
+              <a:srgbClr val="DEE2E6"/>
+            </a:solidFill>
+            <a:prstDash val="solid"/>
+          </a:ln>
+          <a:effectLst>
+            <a:outerShdw sx="100000" sy="100000" kx="0" ky="0" algn="bl" rotWithShape="0" blurRad="76200" dist="25400" dir="5400000">
+              <a:srgbClr val="000000">
+                <a:alpha val="18000"/>
+              </a:srgbClr>
+            </a:outerShdw>
+          </a:effectLst>
+        </p:spPr>
+      </p:sp>
+      <p:pic>
+        <p:nvPicPr>
+          <p:cNvPr id="7" name="Móvil en la tablet" descr="Móvil en la tablet">    </p:cNvPr>
+          <p:cNvPicPr>
+            <a:picLocks noChangeAspect="1"/>
+          </p:cNvPicPr>
+          <p:nvPr/>
+        </p:nvPicPr>
+        <p:blipFill>
+          <a:blip r:embed="rId1"/>
+          <a:stretch>
+            <a:fillRect/>
+          </a:stretch>
+        </p:blipFill>
+        <p:spPr>
+          <a:xfrm>
+            <a:off x="5890260" y="1600200"/>
+            <a:ext cx="4267200" cy="2560320"/>
+          </a:xfrm>
+          <a:prstGeom prst="rect">
+            <a:avLst/>
+          </a:prstGeom>
+        </p:spPr>
+      </p:pic>
+      <p:sp>
+        <p:nvSpPr>
+          <p:cNvPr id="8" name="Caja código móvil"/>
+          <p:cNvSpPr/>
+          <p:nvPr/>
+        </p:nvSpPr>
+        <p:spPr>
+          <a:xfrm>
+            <a:off x="4389120" y="4297680"/>
             <a:ext cx="7269480" cy="1920240"/>
           </a:xfrm>
           <a:prstGeom prst="roundRect">
@@ -3940,13 +3996,13 @@
       </p:sp>
       <p:sp>
         <p:nvSpPr>
-          <p:cNvPr id="7" name="Text 4"/>
+          <p:cNvPr id="9" name="Text 5"/>
           <p:cNvSpPr txBox="1"/>
           <p:nvPr/>
         </p:nvSpPr>
         <p:spPr>
           <a:xfrm>
-            <a:off x="4480560" y="1783080"/>
+            <a:off x="4480560" y="4389120"/>
             <a:ext cx="7086600" cy="1737360"/>
           </a:xfrm>
           <a:prstGeom prst="rect">
@@ -4364,7 +4420,7 @@
                 <a:ea typeface="Calibri" pitchFamily="34" charset="-122"/>
                 <a:cs typeface="Calibri" pitchFamily="34" charset="-120"/>
               </a:rPr>
-              <a:t>Ctrl + F5 en Visual Studio (Kestrel en http://*:8086) y abrir_puerto_red.ps1 una vez</a:t>
+              <a:t>Publica el API en IIS con publicar_iis.ps1 (sitio CONUNI_REST, puerto 8086 y firewall)</a:t>
             </a:r>
             <a:endParaRPr lang="en-US" sz="1500" dirty="0"/>
           </a:p>
@@ -5018,8 +5074,8 @@
         </p:blipFill>
         <p:spPr>
           <a:xfrm>
-            <a:off x="917926" y="1234440"/>
-            <a:ext cx="6759507" cy="4983480"/>
+            <a:off x="548640" y="1579861"/>
+            <a:ext cx="7498080" cy="4292638"/>
           </a:xfrm>
           <a:prstGeom prst="rect">
             <a:avLst/>
@@ -7844,7 +7900,7 @@
                 <a:ea typeface="Calibri" pitchFamily="34" charset="-122"/>
                 <a:cs typeface="Calibri" pitchFamily="34" charset="-120"/>
               </a:rPr>
-              <a:t>Swagger sirvió como contrato y como herramienta de pruebas; Kestrel simplificó el despliegue en red.</a:t>
+              <a:t>Swagger sirvió como contrato y como herramienta de pruebas; publicado en IIS, el API queda disponible en la red.</a:t>
             </a:r>
             <a:endParaRPr lang="en-US" sz="2100" dirty="0"/>
           </a:p>
@@ -8584,8 +8640,8 @@
         </p:blipFill>
         <p:spPr>
           <a:xfrm>
-            <a:off x="1158747" y="1234440"/>
-            <a:ext cx="5729226" cy="4983480"/>
+            <a:off x="1217269" y="1234440"/>
+            <a:ext cx="5612183" cy="4983480"/>
           </a:xfrm>
           <a:prstGeom prst="rect">
             <a:avLst/>
@@ -8728,7 +8784,7 @@
                 <a:ea typeface="Calibri" pitchFamily="34" charset="-122"/>
                 <a:cs typeface="Calibri" pitchFamily="34" charset="-120"/>
               </a:rPr>
-              <a:t>Verbos HTTP sobre recursos, Kestrel :8086</a:t>
+              <a:t>Verbos HTTP sobre recursos, IIS :8086</a:t>
             </a:r>
             <a:endParaRPr lang="en-US" sz="1400" dirty="0"/>
           </a:p>
@@ -10498,7 +10554,7 @@
                 <a:ea typeface="Consolas" pitchFamily="34" charset="-122"/>
                 <a:cs typeface="Consolas" pitchFamily="34" charset="-120"/>
               </a:rPr>
-              <a:t>Host: 10.12.46.165:8086</a:t>
+              <a:t>Host: IP-DEL-SERVIDOR:8086</a:t>
             </a:r>
             <a:endParaRPr lang="en-US" sz="1400" dirty="0"/>
           </a:p>
@@ -10936,7 +10992,24 @@
                 <a:ea typeface="Consolas" pitchFamily="34" charset="-122"/>
                 <a:cs typeface="Consolas" pitchFamily="34" charset="-120"/>
               </a:rPr>
-              <a:t>401 → { "codigo": "CREDENCIALES_INVALIDAS" }</a:t>
+              <a:t>401 → { "codigo": "REGLA_NEGOCIO",</a:t>
+            </a:r>
+            <a:endParaRPr lang="en-US" sz="1400" dirty="0"/>
+          </a:p>
+          <a:p>
+            <a:pPr indent="0" marL="0">
+              <a:buNone/>
+            </a:pPr>
+            <a:r>
+              <a:rPr lang="en-US" sz="1400" dirty="0">
+                <a:solidFill>
+                  <a:srgbClr val="212529"/>
+                </a:solidFill>
+                <a:latin typeface="Consolas" pitchFamily="34" charset="0"/>
+                <a:ea typeface="Consolas" pitchFamily="34" charset="-122"/>
+                <a:cs typeface="Consolas" pitchFamily="34" charset="-120"/>
+              </a:rPr>
+              <a:t>        "mensaje": "...Intentos restantes: 2." }</a:t>
             </a:r>
             <a:endParaRPr lang="en-US" sz="1400" dirty="0"/>
           </a:p>
@@ -11061,8 +11134,8 @@
         </p:nvSpPr>
         <p:spPr>
           <a:xfrm>
-            <a:off x="1395774" y="1197864"/>
-            <a:ext cx="4340773" cy="5056632"/>
+            <a:off x="1416207" y="1197864"/>
+            <a:ext cx="4299907" cy="5056632"/>
           </a:xfrm>
           <a:prstGeom prst="rect">
             <a:avLst/>
@@ -11101,8 +11174,8 @@
         </p:blipFill>
         <p:spPr>
           <a:xfrm>
-            <a:off x="1432350" y="1234440"/>
-            <a:ext cx="4267621" cy="4983480"/>
+            <a:off x="1452783" y="1234440"/>
+            <a:ext cx="4226755" cy="4983480"/>
           </a:xfrm>
           <a:prstGeom prst="rect">
             <a:avLst/>
@@ -11715,7 +11788,7 @@
                             <a:srgbClr val="212529"/>
                           </a:solidFill>
                         </a:rPr>
-                        <a:t>ASP.NET Core Web API · .NET 9 · Kestrel :8086</a:t>
+                        <a:t>ASP.NET Core Web API · .NET 9 · IIS :8086 (Hosting Bundle)</a:t>
                       </a:r>
                       <a:endParaRPr lang="en-US" sz="1500" dirty="0"/>
                     </a:p>
@@ -12825,7 +12898,7 @@
                             <a:srgbClr val="212529"/>
                           </a:solidFill>
                         </a:rPr>
-                        <a:t>Abrir el puerto 8086 en el firewall</a:t>
+                        <a:t>Publicar en IIS con el Hosting Bundle (script)</a:t>
                       </a:r>
                       <a:endParaRPr lang="en-US" sz="1500" dirty="0"/>
                     </a:p>
@@ -13788,7 +13861,7 @@
                 <a:ea typeface="Calibri" pitchFamily="34" charset="-122"/>
                 <a:cs typeface="Calibri" pitchFamily="34" charset="-120"/>
               </a:rPr>
-              <a:t>Red sin IIS</a:t>
+              <a:t>Publicado en IIS</a:t>
             </a:r>
             <a:endParaRPr lang="en-US" sz="1700" dirty="0"/>
           </a:p>
@@ -13827,7 +13900,7 @@
                 <a:ea typeface="Calibri" pitchFamily="34" charset="-122"/>
                 <a:cs typeface="Calibri" pitchFamily="34" charset="-120"/>
               </a:rPr>
-              <a:t>Kestrel en http://*:8086 y un script que abre el firewall</a:t>
+              <a:t>Sitio CONUNI_REST :8086 con publicar_iis.ps1; encendido siempre</a:t>
             </a:r>
             <a:endParaRPr lang="en-US" sz="1400" dirty="0"/>
           </a:p>
@@ -14287,8 +14360,8 @@
         </p:nvSpPr>
         <p:spPr>
           <a:xfrm>
-            <a:off x="5702803" y="1609344"/>
-            <a:ext cx="4642114" cy="2221992"/>
+            <a:off x="6375654" y="1609344"/>
+            <a:ext cx="3296412" cy="2221992"/>
           </a:xfrm>
           <a:prstGeom prst="rect">
             <a:avLst/>
@@ -14327,8 +14400,8 @@
         </p:blipFill>
         <p:spPr>
           <a:xfrm>
-            <a:off x="5739379" y="1645920"/>
-            <a:ext cx="4568962" cy="2148840"/>
+            <a:off x="6412230" y="1645920"/>
+            <a:ext cx="3223260" cy="2148840"/>
           </a:xfrm>
           <a:prstGeom prst="rect">
             <a:avLst/>
@@ -14343,8 +14416,8 @@
         </p:nvSpPr>
         <p:spPr>
           <a:xfrm>
-            <a:off x="5261468" y="3941064"/>
-            <a:ext cx="5524784" cy="2313432"/>
+            <a:off x="6307074" y="3941064"/>
+            <a:ext cx="3433572" cy="2313432"/>
           </a:xfrm>
           <a:prstGeom prst="rect">
             <a:avLst/>
@@ -14383,8 +14456,8 @@
         </p:blipFill>
         <p:spPr>
           <a:xfrm>
-            <a:off x="5298044" y="3977640"/>
-            <a:ext cx="5451632" cy="2240280"/>
+            <a:off x="6343650" y="3977640"/>
+            <a:ext cx="3360420" cy="2240280"/>
           </a:xfrm>
           <a:prstGeom prst="rect">
             <a:avLst/>

</xml_diff>

<commit_message>
Renumerar capturas de escritorio y web sin huecos; manual y presentacion regenerados
</commit_message>
<xml_diff>
--- a/05. DOCUMENTACIÓN/MANUAL_RESTFUL_DOTNET_GR01.pptx
+++ b/05. DOCUMENTACIÓN/MANUAL_RESTFUL_DOTNET_GR01.pptx
@@ -122,12 +122,12 @@
   <p:extLst>
     <p:ext uri="{521415D9-36F7-43E2-AB2F-B90AF26B5E84}">
       <p14:sectionLst xmlns:p14="http://schemas.microsoft.com/office/powerpoint/2010/main">
-        <p14:section name="Inicio" id="{5f3666ec-4205-65e3-d172-9fff26b8f660}">
+        <p14:section name="Inicio" id="{8dbf34c7-db4b-e329-215e-69403485cc0a}">
           <p14:sldIdLst>
             <p14:sldId id="256"/>
           </p14:sldIdLst>
         </p14:section>
-        <p14:section name="Solución" id="{aecb981a-7f6c-b5ad-e8e3-791074d682c9}">
+        <p14:section name="Solución" id="{b0d56f0b-c5d1-3c95-779c-817e1a97e2b9}">
           <p14:sldIdLst>
             <p14:sldId id="257"/>
             <p14:sldId id="258"/>
@@ -138,7 +138,7 @@
             <p14:sldId id="263"/>
           </p14:sldIdLst>
         </p14:section>
-        <p14:section name="Clientes" id="{4457c14c-b705-8d3f-827e-5f6b584f8916}">
+        <p14:section name="Clientes" id="{d0cbc7f9-458a-61c6-af2c-2ae1a025b79c}">
           <p14:sldIdLst>
             <p14:sldId id="264"/>
             <p14:sldId id="265"/>
@@ -147,13 +147,13 @@
             <p14:sldId id="268"/>
           </p14:sldIdLst>
         </p14:section>
-        <p14:section name="Calidad" id="{03b1fdee-d85d-50f3-ee66-3a6eed56babb}">
+        <p14:section name="Calidad" id="{6b5e5333-9205-c563-7ea1-ef74b1366944}">
           <p14:sldIdLst>
             <p14:sldId id="269"/>
             <p14:sldId id="270"/>
           </p14:sldIdLst>
         </p14:section>
-        <p14:section name="Cierre" id="{558e24d5-7b89-b21b-b355-20392df99be3}">
+        <p14:section name="Cierre" id="{90739ffe-aa53-d6a1-2626-f81f5303cd2f}">
           <p14:sldIdLst>
             <p14:sldId id="271"/>
           </p14:sldIdLst>

</xml_diff>